<commit_message>
Report, PPT and abstract form with final ELA results; app refactor
Co-Authored-By: Claude Opus 5.5 <noreply@anthropic.com>
</commit_message>
<xml_diff>
--- a/report/FinDoc_AI_Review_PPT_Updated.pptx
+++ b/report/FinDoc_AI_Review_PPT_Updated.pptx
@@ -4858,7 +4858,7 @@
                 <a:latin typeface="Times New Roman" panose="02020603050405020304" pitchFamily="18" charset="0"/>
                 <a:cs typeface="Times New Roman" panose="02020603050405020304" pitchFamily="18" charset="0"/>
               </a:rPr>
-              <a:t>Scanned pages: grey-scale, 224×224 windows every 112 px, EfficientNetV2B0 score per window</a:t>
+              <a:t>Scanned pages: Error Level Analysis, re-saved as JPEG (quality 70) and compared</a:t>
             </a:r>
           </a:p>
           <a:p>
@@ -4874,7 +4874,7 @@
                 <a:latin typeface="Times New Roman" panose="02020603050405020304" pitchFamily="18" charset="0"/>
                 <a:cs typeface="Times New Roman" panose="02020603050405020304" pitchFamily="18" charset="0"/>
               </a:rPr>
-              <a:t>Document score = most suspicious window, compared with a threshold chosen on validation data</a:t>
+              <a:t>Score = how far the most unusual 64x64 text region differs (z-score); EfficientNetV2B0-ELA checks it</a:t>
             </a:r>
           </a:p>
           <a:p>
@@ -5013,7 +5013,7 @@
                 <a:latin typeface="Times New Roman" panose="02020603050405020304" pitchFamily="18" charset="0"/>
                 <a:cs typeface="Times New Roman" panose="02020603050405020304" pitchFamily="18" charset="0"/>
               </a:rPr>
-              <a:t>Training patches are 224 × 224 windows cut at the original resolution: 1,638 tampered windows around the 273 annotated edits and 2,695 genuine windows. EfficientNetV2B0 (ImageNet weights) is fine-tuned in two phases with balanced class weights.</a:t>
+              <a:t>ELA re-saves the page as JPEG and measures the re-compression error of every text pixel; edited areas were compressed a different number of times and stand out. EfficientNetV2B0 (ImageNet weights) is fine-tuned on 4,333 ELA patches (1,638 tampered), reaches 80.4% patch AUC, and runs in the web app with ONNX Runtime.</a:t>
             </a:r>
           </a:p>
         </p:txBody>
@@ -5121,7 +5121,7 @@
                 <a:latin typeface="Times New Roman" panose="02020603050405020304" pitchFamily="18" charset="0"/>
                 <a:cs typeface="Times New Roman" panose="02020603050405020304" pitchFamily="18" charset="0"/>
               </a:rPr>
-              <a:t>Accuracy: 43.58%</a:t>
+              <a:t>Accuracy: 71.10%</a:t>
             </a:r>
           </a:p>
           <a:p>
@@ -5137,7 +5137,7 @@
                 <a:latin typeface="Times New Roman" panose="02020603050405020304" pitchFamily="18" charset="0"/>
                 <a:cs typeface="Times New Roman" panose="02020603050405020304" pitchFamily="18" charset="0"/>
               </a:rPr>
-              <a:t>Precision: 16.67%</a:t>
+              <a:t>Precision: 31.08%</a:t>
             </a:r>
           </a:p>
           <a:p>
@@ -5153,7 +5153,7 @@
                 <a:latin typeface="Times New Roman" panose="02020603050405020304" pitchFamily="18" charset="0"/>
                 <a:cs typeface="Times New Roman" panose="02020603050405020304" pitchFamily="18" charset="0"/>
               </a:rPr>
-              <a:t>Recall: 62.86%</a:t>
+              <a:t>Recall: 65.71%</a:t>
             </a:r>
           </a:p>
           <a:p>
@@ -5169,7 +5169,7 @@
                 <a:latin typeface="Times New Roman" panose="02020603050405020304" pitchFamily="18" charset="0"/>
                 <a:cs typeface="Times New Roman" panose="02020603050405020304" pitchFamily="18" charset="0"/>
               </a:rPr>
-              <a:t>F1-score: 26.35%</a:t>
+              <a:t>F1-score: 42.20%</a:t>
             </a:r>
           </a:p>
           <a:p>
@@ -5185,7 +5185,7 @@
                 <a:latin typeface="Times New Roman" panose="02020603050405020304" pitchFamily="18" charset="0"/>
                 <a:cs typeface="Times New Roman" panose="02020603050405020304" pitchFamily="18" charset="0"/>
               </a:rPr>
-              <a:t>ROC-AUC: 47.04% (50% = random guessing)</a:t>
+              <a:t>ROC-AUC: 79.16% (50% = random guessing)</a:t>
             </a:r>
           </a:p>
           <a:p>
@@ -5201,7 +5201,7 @@
                 <a:latin typeface="Times New Roman" panose="02020603050405020304" pitchFamily="18" charset="0"/>
                 <a:cs typeface="Times New Roman" panose="02020603050405020304" pitchFamily="18" charset="0"/>
               </a:rPr>
-              <a:t>Tampered receipts caught: 22 of 35</a:t>
+              <a:t>Tampered receipts caught: 23 of 35</a:t>
             </a:r>
           </a:p>
           <a:p>
@@ -5217,7 +5217,7 @@
                 <a:latin typeface="Times New Roman" panose="02020603050405020304" pitchFamily="18" charset="0"/>
                 <a:cs typeface="Times New Roman" panose="02020603050405020304" pitchFamily="18" charset="0"/>
               </a:rPr>
-              <a:t>Genuine wrongly flagged: 110 of 183</a:t>
+              <a:t>Genuine wrongly flagged: 51 of 183</a:t>
             </a:r>
           </a:p>
         </p:txBody>
@@ -5239,7 +5239,7 @@
         <p:spPr>
           <a:xfrm>
             <a:off x="6150000" y="1500000"/>
-            <a:ext cx="5700000" cy="3065133"/>
+            <a:ext cx="5700000" cy="3065094"/>
           </a:xfrm>
           <a:prstGeom prst="rect">
             <a:avLst/>
@@ -5413,7 +5413,7 @@
                 <a:latin typeface="Times New Roman" panose="02020603050405020304" pitchFamily="18" charset="0"/>
                 <a:cs typeface="Times New Roman" panose="02020603050405020304" pitchFamily="18" charset="0"/>
               </a:rPr>
-              <a:t>Why the Earlier 97.85% Was Misleading:</a:t>
+              <a:t>From 97.85% (Misleading) to a Working Detector:</a:t>
             </a:r>
           </a:p>
           <a:p>
@@ -5435,7 +5435,7 @@
                 <a:latin typeface="Times New Roman" panose="02020603050405020304" pitchFamily="18" charset="0"/>
                 <a:cs typeface="Times New Roman" panose="02020603050405020304" pitchFamily="18" charset="0"/>
               </a:rPr>
-              <a:t>Old tampered patches: tiny crops (~80 px) enlarged 3×; genuine patches: 256 px crops shrunk</a:t>
+              <a:t>Initial CNN: tiny crops enlarged 3× vs large crops shrunk, so it learned the zoom level (97.85% on patches)</a:t>
             </a:r>
           </a:p>
           <a:p>
@@ -5451,7 +5451,7 @@
                 <a:latin typeface="Times New Roman" panose="02020603050405020304" pitchFamily="18" charset="0"/>
                 <a:cs typeface="Times New Roman" panose="02020603050405020304" pitchFamily="18" charset="0"/>
               </a:rPr>
-              <a:t>The model learned the zoom level, not the tampering</a:t>
+              <a:t>Tested on whole receipts: 49.5% accuracy, AUC 0.44, i.e. chance level</a:t>
             </a:r>
           </a:p>
           <a:p>
@@ -5467,7 +5467,7 @@
                 <a:latin typeface="Times New Roman" panose="02020603050405020304" pitchFamily="18" charset="0"/>
                 <a:cs typeface="Times New Roman" panose="02020603050405020304" pitchFamily="18" charset="0"/>
               </a:rPr>
-              <a:t>Tested on whole receipts: 49.5% accuracy, AUC 0.44 (chance level)</a:t>
+              <a:t>Retrained on same-scale pixel patches: still chance level (AUC 0.47, 110 of 183 genuine wrongly flagged)</a:t>
             </a:r>
           </a:p>
           <a:p>
@@ -5483,7 +5483,7 @@
                 <a:latin typeface="Times New Roman" panose="02020603050405020304" pitchFamily="18" charset="0"/>
                 <a:cs typeface="Times New Roman" panose="02020603050405020304" pitchFamily="18" charset="0"/>
               </a:rPr>
-              <a:t>Fix: every patch is a 224×224 window at the original scale, and evaluation uses whole documents</a:t>
+              <a:t>Final system with Error Level Analysis: 71.10% accuracy, AUC 79.16%, 51 of 183 genuine flagged</a:t>
             </a:r>
           </a:p>
           <a:p>
@@ -5499,23 +5499,7 @@
                 <a:latin typeface="Times New Roman" panose="02020603050405020304" pitchFamily="18" charset="0"/>
                 <a:cs typeface="Times New Roman" panose="02020603050405020304" pitchFamily="18" charset="0"/>
               </a:rPr>
-              <a:t>Final model: detects 22 of 35 tampered receipts (was 14) but flags 110 of 183 genuine ones (was 89)</a:t>
-            </a:r>
-          </a:p>
-          <a:p>
-            <a:pPr marL="342900" lvl="0" indent="-342900">
-              <a:lnSpc>
-                <a:spcPct val="125000"/>
-              </a:lnSpc>
-              <a:buFont typeface="Arial" panose="020B0604020202020204" pitchFamily="34" charset="0"/>
-              <a:buChar char="•"/>
-            </a:pPr>
-            <a:r>
-              <a:rPr lang="en-IN" sz="1700" dirty="0">
-                <a:latin typeface="Times New Roman" panose="02020603050405020304" pitchFamily="18" charset="0"/>
-                <a:cs typeface="Times New Roman" panose="02020603050405020304" pitchFamily="18" charset="0"/>
-              </a:rPr>
-              <a:t>The final numbers are lower, but they describe what users of the website actually get</a:t>
+              <a:t>Lesson: evaluate on whole documents, exactly as the application is used</a:t>
             </a:r>
           </a:p>
         </p:txBody>
@@ -5599,7 +5583,7 @@
         <p:spPr>
           <a:xfrm>
             <a:off x="420000" y="1450000"/>
-            <a:ext cx="5550000" cy="4400357"/>
+            <a:ext cx="5550000" cy="5074286"/>
           </a:xfrm>
           <a:prstGeom prst="rect">
             <a:avLst/>
@@ -5623,7 +5607,7 @@
         <p:spPr>
           <a:xfrm>
             <a:off x="6150000" y="1450000"/>
-            <a:ext cx="5600000" cy="4120000"/>
+            <a:ext cx="5600000" cy="4080000"/>
           </a:xfrm>
           <a:prstGeom prst="rect">
             <a:avLst/>
@@ -6003,7 +5987,7 @@
             </a:pPr>
             <a:r>
               <a:rPr lang="en-IN" dirty="0" sz="1600"/>
-              <a:t>Why the Earlier 97.85% Was Misleading</a:t>
+              <a:t>From 97.85% to a Working Detector</a:t>
             </a:r>
           </a:p>
           <a:p>
@@ -6498,7 +6482,7 @@
                 <a:latin typeface="Times New Roman" panose="02020603050405020304" pitchFamily="18" charset="0"/>
                 <a:cs typeface="Times New Roman" panose="02020603050405020304" pitchFamily="18" charset="0"/>
               </a:rPr>
-              <a:t>Financial document tampering is a serious problem for banks, insurance companies and businesses. This project presents FinDoc AI, an explainable tampering detection system based on EfficientNetV2B0 and Grad-CAM, trained on the public “Find it again!” dataset of 988 scanned receipts. The model is fine-tuned on 224 × 224 windows cut at the receipts’ original resolution, and whole documents are scanned with overlapping windows; Grad-CAM heatmaps and a plain-language list of reasons explain every decision. The Flask web application accepts images, camera photos, PDF, Word and PowerPoint files, and checks the metadata of digital files. An earlier model that reported 97.85% patch accuracy was found to perform at chance level on whole receipts; the final system reaches 43.58% accuracy and a document-level AUC of 47.04% on 218 test receipts, so it is best used as an explainable screening aid.</a:t>
+              <a:t>Financial document tampering is a serious problem for banks, insurance companies and businesses. FinDoc AI detects tampered receipts and invoices and explains every decision. It is trained and evaluated on the public “Find it again!” dataset of 988 scanned receipts. Error Level Analysis (ELA) re-saves the page as JPEG and finds text regions whose compression error differs from the rest, which is typical of pasted or re-typed content. EfficientNetV2B0, fine-tuned on ELA maps, classifies the most suspicious regions, and Grad-CAM heatmaps with plain-language reasons explain the result. Typed Word, PowerPoint and digital PDF files are checked through their metadata. The Flask web application is deployed on Vercel and accepts images, camera photos, PDF, Word and PowerPoint files. On 218 test receipts the system reaches 71.10% accuracy and a document-level AUC of 79.16%, detecting 23 of 35 tampered receipts.</a:t>
             </a:r>
           </a:p>
         </p:txBody>
@@ -6844,7 +6828,7 @@
                 <a:latin typeface="Times New Roman" panose="02020603050405020304" pitchFamily="18" charset="0"/>
                 <a:cs typeface="Times New Roman" panose="02020603050405020304" pitchFamily="18" charset="0"/>
               </a:rPr>
-              <a:t>FinDoc AI provides a complete, explainable pipeline: any image, PDF, Word or PowerPoint file can be uploaded, scanned documents are analysed window by window with EfficientNetV2B0, and every result is explained with Grad-CAM, flagged regions and reasons. A careful document-level evaluation showed that detecting careful manual edits in scanned receipts is still hard: the honest test AUC is 47.04%, so the system should be used as a screening aid, not as proof.</a:t>
+              <a:t>FinDoc AI provides a complete, explainable pipeline: images, PDF, Word and PowerPoint files are analysed with Error Level Analysis and an EfficientNetV2B0 model trained on ELA maps, digital files are checked through their metadata, and every result is explained with heatmaps, Grad-CAM and reasons. On whole test receipts it reaches 71.10% accuracy and an AUC of 79.16%; it is an explainable screening aid, live at findoc-ai.vercel.app.</a:t>
             </a:r>
           </a:p>
           <a:p>
@@ -6912,14 +6896,14 @@
                 <a:latin typeface="Times New Roman" panose="02020603050405020304" pitchFamily="18" charset="0"/>
                 <a:cs typeface="Times New Roman" panose="02020603050405020304" pitchFamily="18" charset="0"/>
               </a:rPr>
-              <a:t>Models: </a:t>
+              <a:t>Forensics: </a:t>
             </a:r>
             <a:r>
               <a:rPr lang="en-IN" sz="1800" dirty="0">
                 <a:latin typeface="Times New Roman" panose="02020603050405020304" pitchFamily="18" charset="0"/>
                 <a:cs typeface="Times New Roman" panose="02020603050405020304" pitchFamily="18" charset="0"/>
               </a:rPr>
-              <a:t>Forensic networks trained with pixel-level masks</a:t>
+              <a:t>Copy-move and double-JPEG analysis for images compressed many times</a:t>
             </a:r>
           </a:p>
         </p:txBody>

</xml_diff>